<commit_message>
deck: refine presentation stage color definitions and semantics
Adjusted the color assignments for the presentation's stage progression
(Amber, Teal, Violet) to align with a warm → neutral → brand sequence
(dark red → slate → blue).

Updated comments in `build_deck.py` to include a semantic rationale for
each stage, linking the colors to architectural concepts:
Stage 1 (procedural) as "the legacy that hurts",
Stage 2 (inheritance) as "the bridge", and
Stage 3 (composition) as "brand climax".

Updated the main workshop presentation (`NEM2026_workshop.pptx`) and
removed an outdated presentation file (`SPT Framework_03_16_23.pptx`).
</commit_message>
<xml_diff>
--- a/presentation/NEM2026_workshop.pptx
+++ b/presentation/NEM2026_workshop.pptx
@@ -29171,7 +29171,7 @@
             <a:r>
               <a:rPr sz="1000" b="1" i="0">
                 <a:solidFill>
-                  <a:srgbClr val="414D5C"/>
+                  <a:srgbClr val="770000"/>
                 </a:solidFill>
                 <a:latin typeface="Arial"/>
               </a:rPr>
@@ -29254,7 +29254,7 @@
             <a:r>
               <a:rPr sz="1000" b="1" i="0">
                 <a:solidFill>
-                  <a:srgbClr val="414D5C"/>
+                  <a:srgbClr val="770000"/>
                 </a:solidFill>
                 <a:latin typeface="Arial"/>
               </a:rPr>
@@ -29595,7 +29595,7 @@
             <a:r>
               <a:rPr sz="1000" b="1" i="0">
                 <a:solidFill>
-                  <a:srgbClr val="414D5C"/>
+                  <a:srgbClr val="770000"/>
                 </a:solidFill>
                 <a:latin typeface="Arial"/>
               </a:rPr>
@@ -29678,7 +29678,7 @@
             <a:r>
               <a:rPr sz="1000" b="1" i="0">
                 <a:solidFill>
-                  <a:srgbClr val="414D5C"/>
+                  <a:srgbClr val="770000"/>
                 </a:solidFill>
                 <a:latin typeface="Arial"/>
               </a:rPr>
@@ -30015,7 +30015,7 @@
             <a:r>
               <a:rPr sz="16000" b="0" i="0">
                 <a:solidFill>
-                  <a:srgbClr val="414D5C"/>
+                  <a:srgbClr val="770000"/>
                 </a:solidFill>
                 <a:latin typeface="Georgia"/>
               </a:rPr>
@@ -30553,7 +30553,7 @@
             <a:r>
               <a:rPr sz="2200" b="1">
                 <a:solidFill>
-                  <a:srgbClr val="414D5C"/>
+                  <a:srgbClr val="770000"/>
                 </a:solidFill>
                 <a:latin typeface="Arial"/>
               </a:rPr>
@@ -30581,7 +30581,7 @@
             <a:r>
               <a:rPr sz="2200" b="1">
                 <a:solidFill>
-                  <a:srgbClr val="414D5C"/>
+                  <a:srgbClr val="770000"/>
                 </a:solidFill>
                 <a:latin typeface="Arial"/>
               </a:rPr>
@@ -30618,7 +30618,7 @@
             <a:r>
               <a:rPr sz="2200" b="1">
                 <a:solidFill>
-                  <a:srgbClr val="414D5C"/>
+                  <a:srgbClr val="770000"/>
                 </a:solidFill>
                 <a:latin typeface="Arial"/>
               </a:rPr>
@@ -30687,7 +30687,7 @@
             <a:r>
               <a:rPr sz="1000" b="1" i="0">
                 <a:solidFill>
-                  <a:srgbClr val="414D5C"/>
+                  <a:srgbClr val="770000"/>
                 </a:solidFill>
                 <a:latin typeface="Arial"/>
               </a:rPr>
@@ -30965,7 +30965,7 @@
             <a:r>
               <a:rPr sz="1000" b="1" i="0">
                 <a:solidFill>
-                  <a:srgbClr val="414D5C"/>
+                  <a:srgbClr val="770000"/>
                 </a:solidFill>
                 <a:latin typeface="Arial"/>
               </a:rPr>
@@ -31043,7 +31043,7 @@
             <a:r>
               <a:rPr sz="6400" b="1" i="0">
                 <a:solidFill>
-                  <a:srgbClr val="414D5C"/>
+                  <a:srgbClr val="770000"/>
                 </a:solidFill>
                 <a:latin typeface="Arial"/>
               </a:rPr>
@@ -31067,7 +31067,7 @@
             <a:avLst/>
           </a:prstGeom>
           <a:solidFill>
-            <a:srgbClr val="414D5C"/>
+            <a:srgbClr val="770000"/>
           </a:solidFill>
           <a:ln>
             <a:noFill/>
@@ -31126,7 +31126,7 @@
             <a:r>
               <a:rPr sz="1800" b="1">
                 <a:solidFill>
-                  <a:srgbClr val="414D5C"/>
+                  <a:srgbClr val="770000"/>
                 </a:solidFill>
                 <a:latin typeface="Arial"/>
               </a:rPr>
@@ -31154,7 +31154,7 @@
             <a:r>
               <a:rPr sz="1800" b="1">
                 <a:solidFill>
-                  <a:srgbClr val="414D5C"/>
+                  <a:srgbClr val="770000"/>
                 </a:solidFill>
                 <a:latin typeface="Arial"/>
               </a:rPr>
@@ -31191,7 +31191,7 @@
             <a:r>
               <a:rPr sz="1800" b="1">
                 <a:solidFill>
-                  <a:srgbClr val="414D5C"/>
+                  <a:srgbClr val="770000"/>
                 </a:solidFill>
                 <a:latin typeface="Arial"/>
               </a:rPr>
@@ -31660,7 +31660,7 @@
             <a:r>
               <a:rPr sz="2000" b="1">
                 <a:solidFill>
-                  <a:srgbClr val="414D5C"/>
+                  <a:srgbClr val="770000"/>
                 </a:solidFill>
                 <a:latin typeface="Arial"/>
               </a:rPr>
@@ -31697,7 +31697,7 @@
             <a:r>
               <a:rPr sz="2000" b="1">
                 <a:solidFill>
-                  <a:srgbClr val="414D5C"/>
+                  <a:srgbClr val="770000"/>
                 </a:solidFill>
                 <a:latin typeface="Arial"/>
               </a:rPr>
@@ -31734,7 +31734,7 @@
             <a:r>
               <a:rPr sz="2000" b="1">
                 <a:solidFill>
-                  <a:srgbClr val="414D5C"/>
+                  <a:srgbClr val="770000"/>
                 </a:solidFill>
                 <a:latin typeface="Arial"/>
               </a:rPr>
@@ -31803,7 +31803,7 @@
             <a:r>
               <a:rPr sz="1000" b="1" i="0">
                 <a:solidFill>
-                  <a:srgbClr val="414D5C"/>
+                  <a:srgbClr val="770000"/>
                 </a:solidFill>
                 <a:latin typeface="Arial"/>
               </a:rPr>
@@ -31881,7 +31881,7 @@
             <a:r>
               <a:rPr sz="1000" b="1" i="0">
                 <a:solidFill>
-                  <a:srgbClr val="414D5C"/>
+                  <a:srgbClr val="770000"/>
                 </a:solidFill>
                 <a:latin typeface="Arial"/>
               </a:rPr>
@@ -31959,7 +31959,7 @@
             <a:r>
               <a:rPr sz="6400" b="1" i="0">
                 <a:solidFill>
-                  <a:srgbClr val="414D5C"/>
+                  <a:srgbClr val="770000"/>
                 </a:solidFill>
                 <a:latin typeface="Arial"/>
               </a:rPr>
@@ -31983,7 +31983,7 @@
             <a:avLst/>
           </a:prstGeom>
           <a:solidFill>
-            <a:srgbClr val="414D5C"/>
+            <a:srgbClr val="770000"/>
           </a:solidFill>
           <a:ln>
             <a:noFill/>
@@ -32042,7 +32042,7 @@
             <a:r>
               <a:rPr sz="1800" b="1">
                 <a:solidFill>
-                  <a:srgbClr val="414D5C"/>
+                  <a:srgbClr val="770000"/>
                 </a:solidFill>
                 <a:latin typeface="Arial"/>
               </a:rPr>
@@ -32070,7 +32070,7 @@
             <a:r>
               <a:rPr sz="1800" b="1">
                 <a:solidFill>
-                  <a:srgbClr val="414D5C"/>
+                  <a:srgbClr val="770000"/>
                 </a:solidFill>
                 <a:latin typeface="Arial"/>
               </a:rPr>
@@ -32107,7 +32107,7 @@
             <a:r>
               <a:rPr sz="1800" b="1">
                 <a:solidFill>
-                  <a:srgbClr val="414D5C"/>
+                  <a:srgbClr val="770000"/>
                 </a:solidFill>
                 <a:latin typeface="Arial"/>
               </a:rPr>
@@ -32387,7 +32387,7 @@
             <a:r>
               <a:rPr sz="2000" b="1">
                 <a:solidFill>
-                  <a:srgbClr val="414D5C"/>
+                  <a:srgbClr val="770000"/>
                 </a:solidFill>
                 <a:latin typeface="Arial"/>
               </a:rPr>
@@ -32415,7 +32415,7 @@
             <a:r>
               <a:rPr sz="2000" b="1">
                 <a:solidFill>
-                  <a:srgbClr val="414D5C"/>
+                  <a:srgbClr val="770000"/>
                 </a:solidFill>
                 <a:latin typeface="Arial"/>
               </a:rPr>
@@ -32443,7 +32443,7 @@
             <a:r>
               <a:rPr sz="2000" b="1">
                 <a:solidFill>
-                  <a:srgbClr val="414D5C"/>
+                  <a:srgbClr val="770000"/>
                 </a:solidFill>
                 <a:latin typeface="Arial"/>
               </a:rPr>
@@ -32512,7 +32512,7 @@
             <a:r>
               <a:rPr sz="1000" b="1" i="0">
                 <a:solidFill>
-                  <a:srgbClr val="414D5C"/>
+                  <a:srgbClr val="770000"/>
                 </a:solidFill>
                 <a:latin typeface="Arial"/>
               </a:rPr>
@@ -32590,7 +32590,7 @@
             <a:r>
               <a:rPr sz="1000" b="1" i="0">
                 <a:solidFill>
-                  <a:srgbClr val="414D5C"/>
+                  <a:srgbClr val="770000"/>
                 </a:solidFill>
                 <a:latin typeface="Arial"/>
               </a:rPr>
@@ -32668,7 +32668,7 @@
             <a:r>
               <a:rPr sz="6400" b="1" i="0">
                 <a:solidFill>
-                  <a:srgbClr val="414D5C"/>
+                  <a:srgbClr val="770000"/>
                 </a:solidFill>
                 <a:latin typeface="Arial"/>
               </a:rPr>
@@ -32692,7 +32692,7 @@
             <a:avLst/>
           </a:prstGeom>
           <a:solidFill>
-            <a:srgbClr val="414D5C"/>
+            <a:srgbClr val="770000"/>
           </a:solidFill>
           <a:ln>
             <a:noFill/>
@@ -32751,7 +32751,7 @@
             <a:r>
               <a:rPr sz="1800" b="1">
                 <a:solidFill>
-                  <a:srgbClr val="414D5C"/>
+                  <a:srgbClr val="770000"/>
                 </a:solidFill>
                 <a:latin typeface="Arial"/>
               </a:rPr>
@@ -32779,7 +32779,7 @@
             <a:r>
               <a:rPr sz="1800" b="1">
                 <a:solidFill>
-                  <a:srgbClr val="414D5C"/>
+                  <a:srgbClr val="770000"/>
                 </a:solidFill>
                 <a:latin typeface="Arial"/>
               </a:rPr>
@@ -32816,7 +32816,7 @@
             <a:r>
               <a:rPr sz="1800" b="1">
                 <a:solidFill>
-                  <a:srgbClr val="414D5C"/>
+                  <a:srgbClr val="770000"/>
                 </a:solidFill>
                 <a:latin typeface="Arial"/>
               </a:rPr>
@@ -32875,7 +32875,7 @@
             <a:r>
               <a:rPr sz="2200" b="1">
                 <a:solidFill>
-                  <a:srgbClr val="414D5C"/>
+                  <a:srgbClr val="770000"/>
                 </a:solidFill>
                 <a:latin typeface="Arial"/>
               </a:rPr>
@@ -32912,7 +32912,7 @@
             <a:r>
               <a:rPr sz="2200" b="1">
                 <a:solidFill>
-                  <a:srgbClr val="414D5C"/>
+                  <a:srgbClr val="770000"/>
                 </a:solidFill>
                 <a:latin typeface="Arial"/>
               </a:rPr>
@@ -32940,7 +32940,7 @@
             <a:r>
               <a:rPr sz="2200" b="1">
                 <a:solidFill>
-                  <a:srgbClr val="414D5C"/>
+                  <a:srgbClr val="770000"/>
                 </a:solidFill>
                 <a:latin typeface="Arial"/>
               </a:rPr>
@@ -32968,7 +32968,7 @@
             <a:r>
               <a:rPr sz="2200" b="1">
                 <a:solidFill>
-                  <a:srgbClr val="414D5C"/>
+                  <a:srgbClr val="770000"/>
                 </a:solidFill>
                 <a:latin typeface="Arial"/>
               </a:rPr>
@@ -33037,7 +33037,7 @@
             <a:r>
               <a:rPr sz="1000" b="1" i="0">
                 <a:solidFill>
-                  <a:srgbClr val="414D5C"/>
+                  <a:srgbClr val="770000"/>
                 </a:solidFill>
                 <a:latin typeface="Arial"/>
               </a:rPr>
@@ -33159,7 +33159,7 @@
             <a:r>
               <a:rPr sz="1400" b="1" i="0">
                 <a:solidFill>
-                  <a:srgbClr val="414D5C"/>
+                  <a:srgbClr val="770000"/>
                 </a:solidFill>
                 <a:latin typeface="Arial"/>
               </a:rPr>
@@ -42186,7 +42186,7 @@
             <a:avLst/>
           </a:prstGeom>
           <a:solidFill>
-            <a:srgbClr val="414D5C"/>
+            <a:srgbClr val="770000"/>
           </a:solidFill>
           <a:ln>
             <a:noFill/>
@@ -42284,7 +42284,7 @@
             <a:r>
               <a:rPr sz="1800" b="1" i="0">
                 <a:solidFill>
-                  <a:srgbClr val="414D5C"/>
+                  <a:srgbClr val="770000"/>
                 </a:solidFill>
                 <a:latin typeface="Arial"/>
               </a:rPr>
@@ -46058,7 +46058,7 @@
             <a:avLst/>
           </a:prstGeom>
           <a:solidFill>
-            <a:srgbClr val="414D5C"/>
+            <a:srgbClr val="770000"/>
           </a:solidFill>
           <a:ln>
             <a:noFill/>
@@ -46156,7 +46156,7 @@
             <a:r>
               <a:rPr sz="1400" b="1">
                 <a:solidFill>
-                  <a:srgbClr val="414D5C"/>
+                  <a:srgbClr val="770000"/>
                 </a:solidFill>
                 <a:latin typeface="Arial"/>
               </a:rPr>
@@ -46184,7 +46184,7 @@
             <a:r>
               <a:rPr sz="1400" b="1">
                 <a:solidFill>
-                  <a:srgbClr val="414D5C"/>
+                  <a:srgbClr val="770000"/>
                 </a:solidFill>
                 <a:latin typeface="Arial"/>
               </a:rPr>
@@ -46212,7 +46212,7 @@
             <a:r>
               <a:rPr sz="1400" b="1">
                 <a:solidFill>
-                  <a:srgbClr val="414D5C"/>
+                  <a:srgbClr val="770000"/>
                 </a:solidFill>
                 <a:latin typeface="Arial"/>
               </a:rPr>
@@ -46240,7 +46240,7 @@
             <a:r>
               <a:rPr sz="1400" b="1">
                 <a:solidFill>
-                  <a:srgbClr val="414D5C"/>
+                  <a:srgbClr val="770000"/>
                 </a:solidFill>
                 <a:latin typeface="Arial"/>
               </a:rPr>
@@ -46268,7 +46268,7 @@
             <a:r>
               <a:rPr sz="1400" b="1">
                 <a:solidFill>
-                  <a:srgbClr val="414D5C"/>
+                  <a:srgbClr val="770000"/>
                 </a:solidFill>
                 <a:latin typeface="Arial"/>
               </a:rPr>
@@ -46873,7 +46873,7 @@
             <a:r>
               <a:rPr sz="2200" b="1">
                 <a:solidFill>
-                  <a:srgbClr val="414D5C"/>
+                  <a:srgbClr val="770000"/>
                 </a:solidFill>
                 <a:latin typeface="Arial"/>
               </a:rPr>
@@ -46910,7 +46910,7 @@
             <a:r>
               <a:rPr sz="2200" b="1">
                 <a:solidFill>
-                  <a:srgbClr val="414D5C"/>
+                  <a:srgbClr val="770000"/>
                 </a:solidFill>
                 <a:latin typeface="Arial"/>
               </a:rPr>
@@ -46947,7 +46947,7 @@
             <a:r>
               <a:rPr sz="2200" b="1">
                 <a:solidFill>
-                  <a:srgbClr val="414D5C"/>
+                  <a:srgbClr val="770000"/>
                 </a:solidFill>
                 <a:latin typeface="Arial"/>
               </a:rPr>
@@ -46984,7 +46984,7 @@
             <a:r>
               <a:rPr sz="2200" b="1">
                 <a:solidFill>
-                  <a:srgbClr val="414D5C"/>
+                  <a:srgbClr val="770000"/>
                 </a:solidFill>
                 <a:latin typeface="Arial"/>
               </a:rPr>
@@ -47062,7 +47062,7 @@
             <a:r>
               <a:rPr sz="1000" b="1" i="0">
                 <a:solidFill>
-                  <a:srgbClr val="414D5C"/>
+                  <a:srgbClr val="770000"/>
                 </a:solidFill>
                 <a:latin typeface="Arial"/>
               </a:rPr>
@@ -49941,7 +49941,7 @@
             <a:r>
               <a:rPr sz="2000" b="1">
                 <a:solidFill>
-                  <a:srgbClr val="414D5C"/>
+                  <a:srgbClr val="770000"/>
                 </a:solidFill>
                 <a:latin typeface="Arial"/>
               </a:rPr>
@@ -49978,7 +49978,7 @@
             <a:r>
               <a:rPr sz="2000" b="1">
                 <a:solidFill>
-                  <a:srgbClr val="414D5C"/>
+                  <a:srgbClr val="770000"/>
                 </a:solidFill>
                 <a:latin typeface="Arial"/>
               </a:rPr>
@@ -50015,7 +50015,7 @@
             <a:r>
               <a:rPr sz="2000" b="1">
                 <a:solidFill>
-                  <a:srgbClr val="414D5C"/>
+                  <a:srgbClr val="770000"/>
                 </a:solidFill>
                 <a:latin typeface="Arial"/>
               </a:rPr>
@@ -50052,7 +50052,7 @@
             <a:r>
               <a:rPr sz="2000" b="1">
                 <a:solidFill>
-                  <a:srgbClr val="414D5C"/>
+                  <a:srgbClr val="770000"/>
                 </a:solidFill>
                 <a:latin typeface="Arial"/>
               </a:rPr>
@@ -50089,7 +50089,7 @@
             <a:r>
               <a:rPr sz="2000" b="1">
                 <a:solidFill>
-                  <a:srgbClr val="414D5C"/>
+                  <a:srgbClr val="770000"/>
                 </a:solidFill>
                 <a:latin typeface="Arial"/>
               </a:rPr>
@@ -50167,7 +50167,7 @@
             <a:r>
               <a:rPr sz="1000" b="1" i="0">
                 <a:solidFill>
-                  <a:srgbClr val="414D5C"/>
+                  <a:srgbClr val="770000"/>
                 </a:solidFill>
                 <a:latin typeface="Arial"/>
               </a:rPr>
@@ -50217,7 +50217,7 @@
             <a:r>
               <a:rPr sz="2200" b="1">
                 <a:solidFill>
-                  <a:srgbClr val="414D5C"/>
+                  <a:srgbClr val="770000"/>
                 </a:solidFill>
                 <a:latin typeface="Arial"/>
               </a:rPr>
@@ -50254,7 +50254,7 @@
             <a:r>
               <a:rPr sz="2200" b="1">
                 <a:solidFill>
-                  <a:srgbClr val="414D5C"/>
+                  <a:srgbClr val="770000"/>
                 </a:solidFill>
                 <a:latin typeface="Arial"/>
               </a:rPr>
@@ -50291,7 +50291,7 @@
             <a:r>
               <a:rPr sz="2200" b="1">
                 <a:solidFill>
-                  <a:srgbClr val="414D5C"/>
+                  <a:srgbClr val="770000"/>
                 </a:solidFill>
                 <a:latin typeface="Arial"/>
               </a:rPr>
@@ -50369,7 +50369,7 @@
             <a:r>
               <a:rPr sz="1000" b="1" i="0">
                 <a:solidFill>
-                  <a:srgbClr val="414D5C"/>
+                  <a:srgbClr val="770000"/>
                 </a:solidFill>
                 <a:latin typeface="Arial"/>
               </a:rPr>
@@ -50447,7 +50447,7 @@
             <a:r>
               <a:rPr sz="1000" b="1" i="0">
                 <a:solidFill>
-                  <a:srgbClr val="414D5C"/>
+                  <a:srgbClr val="770000"/>
                 </a:solidFill>
                 <a:latin typeface="Arial"/>
               </a:rPr>
@@ -50530,7 +50530,7 @@
             <a:r>
               <a:rPr sz="1000" b="1" i="0">
                 <a:solidFill>
-                  <a:srgbClr val="414D5C"/>
+                  <a:srgbClr val="770000"/>
                 </a:solidFill>
                 <a:latin typeface="Arial"/>
               </a:rPr>

</xml_diff>